<commit_message>
add logistic regression slides
</commit_message>
<xml_diff>
--- a/slides/09-logistic-regression.pptx
+++ b/slides/09-logistic-regression.pptx
@@ -20,13 +20,13 @@
     <p:sldId id="259" r:id="rId11"/>
     <p:sldId id="260" r:id="rId12"/>
     <p:sldId id="261" r:id="rId13"/>
-    <p:sldId id="262" r:id="rId14"/>
-    <p:sldId id="298" r:id="rId15"/>
-    <p:sldId id="263" r:id="rId16"/>
-    <p:sldId id="299" r:id="rId17"/>
-    <p:sldId id="292" r:id="rId18"/>
-    <p:sldId id="264" r:id="rId19"/>
-    <p:sldId id="293" r:id="rId20"/>
+    <p:sldId id="301" r:id="rId14"/>
+    <p:sldId id="262" r:id="rId15"/>
+    <p:sldId id="298" r:id="rId16"/>
+    <p:sldId id="263" r:id="rId17"/>
+    <p:sldId id="299" r:id="rId18"/>
+    <p:sldId id="292" r:id="rId19"/>
+    <p:sldId id="264" r:id="rId20"/>
   </p:sldIdLst>
   <p:sldSz cx="12192000" cy="6858000"/>
   <p:notesSz cx="6858000" cy="9144000"/>
@@ -215,7 +215,7 @@
           <a:p>
             <a:fld id="{A5320152-7289-42ED-97D3-BBB411F9F8C0}" type="datetimeFigureOut">
               <a:rPr lang="en-US" smtClean="0"/>
-              <a:t>9/21/2026</a:t>
+              <a:t>9/23/2026</a:t>
             </a:fld>
             <a:endParaRPr lang="en-US"/>
           </a:p>
@@ -1104,54 +1104,6 @@
 </p:notes>
 </file>
 
-<file path=ppt/notesSlides/notesSlide19.xml><?xml version="1.0" encoding="utf-8"?>
-<p:notes xmlns:a="http://schemas.openxmlformats.org/drawingml/2006/main" xmlns:r="http://schemas.openxmlformats.org/officeDocument/2006/relationships" xmlns:p="http://schemas.openxmlformats.org/presentationml/2006/main">
-  <p:cSld>
-    <p:spTree>
-      <p:nvGrpSpPr>
-        <p:cNvPr id="1" name=""/>
-        <p:cNvGrpSpPr/>
-        <p:nvPr/>
-      </p:nvGrpSpPr>
-      <p:grpSpPr>
-        <a:xfrm>
-          <a:off x="0" y="0"/>
-          <a:ext cx="0" cy="0"/>
-          <a:chOff x="0" y="0"/>
-          <a:chExt cx="0" cy="0"/>
-        </a:xfrm>
-      </p:grpSpPr>
-      <p:sp>
-        <p:nvSpPr>
-          <p:cNvPr id="2" name="Notes Placeholder 1"/>
-          <p:cNvSpPr>
-            <a:spLocks noGrp="1"/>
-          </p:cNvSpPr>
-          <p:nvPr>
-            <p:ph type="body" idx="1"/>
-          </p:nvPr>
-        </p:nvSpPr>
-        <p:spPr/>
-        <p:txBody>
-          <a:bodyPr/>
-          <a:lstStyle/>
-          <a:p>
-            <a:r>
-              <a:rPr lang="en-US" dirty="0"/>
-              <a:t>Preview only. Separation is worth 30 seconds: perfectly separable data drive the weights to infinity, which is why regularization is standard practice.</a:t>
-            </a:r>
-            <a:endParaRPr lang="en-US"/>
-          </a:p>
-        </p:txBody>
-      </p:sp>
-    </p:spTree>
-  </p:cSld>
-  <p:clrMapOvr>
-    <a:masterClrMapping/>
-  </p:clrMapOvr>
-</p:notes>
-</file>
-
 <file path=ppt/notesSlides/notesSlide2.xml><?xml version="1.0" encoding="utf-8"?>
 <p:notes xmlns:a="http://schemas.openxmlformats.org/drawingml/2006/main" xmlns:r="http://schemas.openxmlformats.org/officeDocument/2006/relationships" xmlns:p="http://schemas.openxmlformats.org/presentationml/2006/main">
   <p:cSld>
@@ -1783,7 +1735,7 @@
           <a:p>
             <a:fld id="{D1D1EADE-8E88-4C7C-8AC5-FB148DE4940E}" type="datetime1">
               <a:rPr lang="en-US" smtClean="0"/>
-              <a:t>9/21/2026</a:t>
+              <a:t>9/23/2026</a:t>
             </a:fld>
             <a:endParaRPr lang="en-US"/>
           </a:p>
@@ -1983,7 +1935,7 @@
           <a:p>
             <a:fld id="{EC3C8B9C-477D-492A-96AD-1FC2CC997A73}" type="datetime1">
               <a:rPr lang="en-US" smtClean="0"/>
-              <a:t>9/21/2026</a:t>
+              <a:t>9/23/2026</a:t>
             </a:fld>
             <a:endParaRPr lang="en-US"/>
           </a:p>
@@ -2193,7 +2145,7 @@
           <a:p>
             <a:fld id="{42D3AED5-E26D-4E29-B1B3-7847B6779594}" type="datetime1">
               <a:rPr lang="en-US" smtClean="0"/>
-              <a:t>9/21/2026</a:t>
+              <a:t>9/23/2026</a:t>
             </a:fld>
             <a:endParaRPr lang="en-US"/>
           </a:p>
@@ -2393,7 +2345,7 @@
           <a:p>
             <a:fld id="{157B6794-849E-4626-908B-D15793550EFB}" type="datetime1">
               <a:rPr lang="en-US" smtClean="0"/>
-              <a:t>9/21/2026</a:t>
+              <a:t>9/23/2026</a:t>
             </a:fld>
             <a:endParaRPr lang="en-US"/>
           </a:p>
@@ -2669,7 +2621,7 @@
           <a:p>
             <a:fld id="{63DB64E7-5594-42A3-ADBF-E95A7ACEAD64}" type="datetime1">
               <a:rPr lang="en-US" smtClean="0"/>
-              <a:t>9/21/2026</a:t>
+              <a:t>9/23/2026</a:t>
             </a:fld>
             <a:endParaRPr lang="en-US"/>
           </a:p>
@@ -2942,7 +2894,7 @@
           <a:p>
             <a:fld id="{18462B0B-D248-4FFB-8695-AD7FA4B1284A}" type="datetime1">
               <a:rPr lang="en-US" smtClean="0"/>
-              <a:t>9/21/2026</a:t>
+              <a:t>9/23/2026</a:t>
             </a:fld>
             <a:endParaRPr lang="en-US"/>
           </a:p>
@@ -3365,7 +3317,7 @@
           <a:p>
             <a:fld id="{D0378EFB-9159-4510-B73F-4F0409ADE937}" type="datetime1">
               <a:rPr lang="en-US" smtClean="0"/>
-              <a:t>9/21/2026</a:t>
+              <a:t>9/23/2026</a:t>
             </a:fld>
             <a:endParaRPr lang="en-US"/>
           </a:p>
@@ -3507,7 +3459,7 @@
           <a:p>
             <a:fld id="{89BC9412-2452-4BED-A324-9D8C115361AD}" type="datetime1">
               <a:rPr lang="en-US" smtClean="0"/>
-              <a:t>9/21/2026</a:t>
+              <a:t>9/23/2026</a:t>
             </a:fld>
             <a:endParaRPr lang="en-US"/>
           </a:p>
@@ -3620,7 +3572,7 @@
           <a:p>
             <a:fld id="{F5318F62-D251-40E8-A23C-F4CFE9FEAB41}" type="datetime1">
               <a:rPr lang="en-US" smtClean="0"/>
-              <a:t>9/21/2026</a:t>
+              <a:t>9/23/2026</a:t>
             </a:fld>
             <a:endParaRPr lang="en-US"/>
           </a:p>
@@ -3933,7 +3885,7 @@
           <a:p>
             <a:fld id="{44F76144-149E-4874-93A5-554A0357CF82}" type="datetime1">
               <a:rPr lang="en-US" smtClean="0"/>
-              <a:t>9/21/2026</a:t>
+              <a:t>9/23/2026</a:t>
             </a:fld>
             <a:endParaRPr lang="en-US"/>
           </a:p>
@@ -4226,7 +4178,7 @@
           <a:p>
             <a:fld id="{50BA65D8-0540-4835-AE5C-25D29DBA01BE}" type="datetime1">
               <a:rPr lang="en-US" smtClean="0"/>
-              <a:t>9/21/2026</a:t>
+              <a:t>9/23/2026</a:t>
             </a:fld>
             <a:endParaRPr lang="en-US"/>
           </a:p>
@@ -4466,7 +4418,7 @@
           <a:p>
             <a:fld id="{E31BA835-12AC-4E8F-955A-EA3F4DE2791F}" type="datetime1">
               <a:rPr lang="en-US" smtClean="0"/>
-              <a:t>9/21/2026</a:t>
+              <a:t>9/23/2026</a:t>
             </a:fld>
             <a:endParaRPr lang="en-US"/>
           </a:p>
@@ -5690,7 +5642,7 @@
         <p:spPr>
           <a:xfrm>
             <a:off x="1981200" y="1950000"/>
-            <a:ext cx="8229600" cy="3159839"/>
+            <a:ext cx="8229600" cy="4090863"/>
           </a:xfrm>
           <a:prstGeom prst="rect">
             <a:avLst/>
@@ -5703,35 +5655,41 @@
           </a:bodyPr>
           <a:lstStyle/>
           <a:p>
-            <a:pPr>
-              <a:spcBef>
-                <a:spcPts val="500"/>
-              </a:spcBef>
-              <a:spcAft>
-                <a:spcPts val="500"/>
-              </a:spcAft>
-            </a:pPr>
-            <a:r>
-              <a:rPr lang="en-US" sz="1500" dirty="0">
+            <a:pPr marL="285750" indent="-285750">
+              <a:spcBef>
+                <a:spcPts val="600"/>
+              </a:spcBef>
+              <a:spcAft>
+                <a:spcPts val="300"/>
+              </a:spcAft>
+              <a:buClr>
+                <a:srgbClr val="13131A"/>
+              </a:buClr>
+              <a:buFont typeface="Arial"/>
+              <a:buChar char="•"/>
+            </a:pPr>
+            <a:r>
+              <a:rPr lang="en-US" dirty="0">
                 <a:solidFill>
                   <a:srgbClr val="13131A"/>
                 </a:solidFill>
               </a:rPr>
               <a:t>Likelihood: how probable the observed data are under the model. For one observation:</a:t>
             </a:r>
-            <a:endParaRPr lang="en-US" sz="1500" dirty="0"/>
-          </a:p>
-          <a:p>
-            <a:pPr>
-              <a:spcBef>
-                <a:spcPts val="500"/>
-              </a:spcBef>
-              <a:spcAft>
-                <a:spcPts val="500"/>
-              </a:spcAft>
-            </a:pPr>
-            <a:r>
-              <a:rPr lang="en-US" sz="1700" dirty="0">
+            <a:endParaRPr lang="en-US" dirty="0"/>
+          </a:p>
+          <a:p>
+            <a:pPr marL="742950" indent="0">
+              <a:spcBef>
+                <a:spcPts val="500"/>
+              </a:spcBef>
+              <a:spcAft>
+                <a:spcPts val="500"/>
+              </a:spcAft>
+              <a:buNone/>
+            </a:pPr>
+            <a:r>
+              <a:rPr lang="en-US" sz="2000" dirty="0">
                 <a:solidFill>
                   <a:srgbClr val="13131A"/>
                 </a:solidFill>
@@ -5740,7 +5698,7 @@
               <a:t>P(y | x) = </a:t>
             </a:r>
             <a:r>
-              <a:rPr lang="en-US" sz="1700" dirty="0" err="1">
+              <a:rPr lang="en-US" sz="2000" dirty="0" err="1">
                 <a:solidFill>
                   <a:srgbClr val="13131A"/>
                 </a:solidFill>
@@ -5749,7 +5707,7 @@
               <a:t>pʸ</a:t>
             </a:r>
             <a:r>
-              <a:rPr lang="en-US" sz="1700" dirty="0">
+              <a:rPr lang="en-US" sz="2000" dirty="0">
                 <a:solidFill>
                   <a:srgbClr val="13131A"/>
                 </a:solidFill>
@@ -5757,57 +5715,68 @@
               </a:rPr>
               <a:t> (1 − p)¹⁻ʸ</a:t>
             </a:r>
-            <a:endParaRPr lang="en-US" sz="1700" dirty="0"/>
-          </a:p>
-          <a:p>
-            <a:pPr>
-              <a:spcBef>
-                <a:spcPts val="500"/>
-              </a:spcBef>
-              <a:spcAft>
-                <a:spcPts val="500"/>
-              </a:spcAft>
-            </a:pPr>
-            <a:r>
-              <a:rPr lang="en-US" sz="1500" dirty="0">
+            <a:endParaRPr lang="en-US" sz="2000" dirty="0"/>
+          </a:p>
+          <a:p>
+            <a:pPr marL="1028700" indent="-228600">
+              <a:spcBef>
+                <a:spcPts val="300"/>
+              </a:spcBef>
+              <a:spcAft>
+                <a:spcPts val="400"/>
+              </a:spcAft>
+              <a:buClr>
+                <a:srgbClr val="595966"/>
+              </a:buClr>
+              <a:buFont typeface="Arial"/>
+              <a:buChar char="–"/>
+            </a:pPr>
+            <a:r>
+              <a:rPr lang="en-US" dirty="0">
                 <a:solidFill>
                   <a:srgbClr val="13131A"/>
                 </a:solidFill>
               </a:rPr>
               <a:t>The exponents just select the right factor: p when y = 1, and 1 − p when y = 0.</a:t>
             </a:r>
-            <a:endParaRPr lang="en-US" sz="1500" dirty="0"/>
-          </a:p>
-          <a:p>
-            <a:pPr>
-              <a:spcBef>
-                <a:spcPts val="500"/>
-              </a:spcBef>
-              <a:spcAft>
-                <a:spcPts val="500"/>
-              </a:spcAft>
-            </a:pPr>
-            <a:r>
-              <a:rPr lang="en-US" sz="1500" b="1" dirty="0">
+            <a:endParaRPr lang="en-US" dirty="0"/>
+          </a:p>
+          <a:p>
+            <a:pPr marL="285750" indent="-285750">
+              <a:spcBef>
+                <a:spcPts val="700"/>
+              </a:spcBef>
+              <a:spcAft>
+                <a:spcPts val="300"/>
+              </a:spcAft>
+              <a:buClr>
+                <a:srgbClr val="13131A"/>
+              </a:buClr>
+              <a:buFont typeface="Arial"/>
+              <a:buChar char="•"/>
+            </a:pPr>
+            <a:r>
+              <a:rPr lang="en-US" b="1" dirty="0">
                 <a:solidFill>
                   <a:srgbClr val="13131A"/>
                 </a:solidFill>
               </a:rPr>
               <a:t>Log-likelihood for n independent observations:</a:t>
             </a:r>
-            <a:endParaRPr lang="en-US" sz="1500" dirty="0"/>
-          </a:p>
-          <a:p>
-            <a:pPr>
-              <a:spcBef>
-                <a:spcPts val="500"/>
-              </a:spcBef>
-              <a:spcAft>
-                <a:spcPts val="500"/>
-              </a:spcAft>
-            </a:pPr>
-            <a:r>
-              <a:rPr lang="en-US" sz="1700" dirty="0">
+            <a:endParaRPr lang="en-US" dirty="0"/>
+          </a:p>
+          <a:p>
+            <a:pPr marL="742950" indent="0">
+              <a:spcBef>
+                <a:spcPts val="500"/>
+              </a:spcBef>
+              <a:spcAft>
+                <a:spcPts val="500"/>
+              </a:spcAft>
+              <a:buNone/>
+            </a:pPr>
+            <a:r>
+              <a:rPr lang="en-US" sz="2000" dirty="0">
                 <a:solidFill>
                   <a:srgbClr val="13131A"/>
                 </a:solidFill>
@@ -5815,38 +5784,44 @@
               </a:rPr>
               <a:t>ℓ(w, b) = Σᵢ [ yᵢ log pᵢ + (1 − yᵢ) log(1 − pᵢ) ]</a:t>
             </a:r>
-            <a:endParaRPr lang="en-US" sz="1700" dirty="0"/>
-          </a:p>
-          <a:p>
-            <a:pPr>
-              <a:spcBef>
-                <a:spcPts val="500"/>
-              </a:spcBef>
-              <a:spcAft>
-                <a:spcPts val="500"/>
-              </a:spcAft>
-            </a:pPr>
-            <a:r>
-              <a:rPr lang="en-US" sz="1500" b="1" dirty="0">
+            <a:endParaRPr lang="en-US" sz="2000" dirty="0"/>
+          </a:p>
+          <a:p>
+            <a:pPr marL="285750" indent="-285750">
+              <a:spcBef>
+                <a:spcPts val="700"/>
+              </a:spcBef>
+              <a:spcAft>
+                <a:spcPts val="300"/>
+              </a:spcAft>
+              <a:buClr>
+                <a:srgbClr val="13131A"/>
+              </a:buClr>
+              <a:buFont typeface="Arial"/>
+              <a:buChar char="•"/>
+            </a:pPr>
+            <a:r>
+              <a:rPr lang="en-US" b="1" dirty="0">
                 <a:solidFill>
                   <a:srgbClr val="13131A"/>
                 </a:solidFill>
               </a:rPr>
               <a:t>Loss = negative log-likelihood, also called cross-entropy loss:</a:t>
             </a:r>
-            <a:endParaRPr lang="en-US" sz="1500" dirty="0"/>
-          </a:p>
-          <a:p>
-            <a:pPr>
-              <a:spcBef>
-                <a:spcPts val="500"/>
-              </a:spcBef>
-              <a:spcAft>
-                <a:spcPts val="500"/>
-              </a:spcAft>
-            </a:pPr>
-            <a:r>
-              <a:rPr lang="en-US" sz="1700" dirty="0">
+            <a:endParaRPr lang="en-US" dirty="0"/>
+          </a:p>
+          <a:p>
+            <a:pPr marL="742950" indent="0">
+              <a:spcBef>
+                <a:spcPts val="500"/>
+              </a:spcBef>
+              <a:spcAft>
+                <a:spcPts val="500"/>
+              </a:spcAft>
+              <a:buNone/>
+            </a:pPr>
+            <a:r>
+              <a:rPr lang="en-US" sz="2000" dirty="0">
                 <a:solidFill>
                   <a:srgbClr val="13131A"/>
                 </a:solidFill>
@@ -5854,26 +5829,31 @@
               </a:rPr>
               <a:t>ℒ(w, b) = − Σᵢ [ yᵢ log pᵢ + (1 − yᵢ) log(1 − pᵢ) ]</a:t>
             </a:r>
-            <a:endParaRPr lang="en-US" sz="1700" dirty="0"/>
-          </a:p>
-          <a:p>
-            <a:pPr>
-              <a:spcBef>
-                <a:spcPts val="500"/>
-              </a:spcBef>
-              <a:spcAft>
-                <a:spcPts val="500"/>
-              </a:spcAft>
-            </a:pPr>
-            <a:r>
-              <a:rPr lang="en-US" sz="1500" dirty="0">
+            <a:endParaRPr lang="en-US" sz="2000" dirty="0"/>
+          </a:p>
+          <a:p>
+            <a:pPr marL="285750" indent="-285750">
+              <a:spcBef>
+                <a:spcPts val="700"/>
+              </a:spcBef>
+              <a:spcAft>
+                <a:spcPts val="300"/>
+              </a:spcAft>
+              <a:buClr>
+                <a:srgbClr val="13131A"/>
+              </a:buClr>
+              <a:buFont typeface="Arial"/>
+              <a:buChar char="•"/>
+            </a:pPr>
+            <a:r>
+              <a:rPr lang="en-US" dirty="0">
                 <a:solidFill>
                   <a:srgbClr val="13131A"/>
                 </a:solidFill>
               </a:rPr>
               <a:t>Maximizing the likelihood is exactly minimizing cross-entropy. A customer who defaulted but was given p ≈ 0 contributes a very large loss.</a:t>
             </a:r>
-            <a:endParaRPr lang="en-US" sz="1500" dirty="0"/>
+            <a:endParaRPr lang="en-US" dirty="0"/>
           </a:p>
         </p:txBody>
       </p:sp>
@@ -6223,7 +6203,7 @@
         <p:spPr>
           <a:xfrm>
             <a:off x="1981200" y="1950000"/>
-            <a:ext cx="5900000" cy="3447098"/>
+            <a:ext cx="5900000" cy="3970318"/>
           </a:xfrm>
           <a:prstGeom prst="rect">
             <a:avLst/>
@@ -6245,14 +6225,14 @@
               </a:spcAft>
             </a:pPr>
             <a:r>
-              <a:rPr lang="en-US" sz="1500" b="1" dirty="0">
+              <a:rPr lang="en-US" b="1" dirty="0">
                 <a:solidFill>
                   <a:srgbClr val="13131A"/>
                 </a:solidFill>
               </a:rPr>
               <a:t>Objective:</a:t>
             </a:r>
-            <a:endParaRPr lang="en-US" sz="1500" dirty="0"/>
+            <a:endParaRPr lang="en-US" dirty="0"/>
           </a:p>
           <a:p>
             <a:pPr>
@@ -6264,7 +6244,7 @@
               </a:spcAft>
             </a:pPr>
             <a:r>
-              <a:rPr lang="en-US" sz="1700" dirty="0">
+              <a:rPr lang="en-US" sz="2000" dirty="0">
                 <a:solidFill>
                   <a:srgbClr val="13131A"/>
                 </a:solidFill>
@@ -6272,7 +6252,7 @@
               </a:rPr>
               <a:t>min over (w, b):  ℒ(w, b)</a:t>
             </a:r>
-            <a:endParaRPr lang="en-US" sz="1700" dirty="0"/>
+            <a:endParaRPr lang="en-US" sz="2000" dirty="0"/>
           </a:p>
           <a:p>
             <a:pPr>
@@ -6284,14 +6264,14 @@
               </a:spcAft>
             </a:pPr>
             <a:r>
-              <a:rPr lang="en-US" sz="1600" b="1" dirty="0">
-                <a:solidFill>
-                  <a:srgbClr val="13131A"/>
-                </a:solidFill>
-              </a:rPr>
-              <a:t>Key properties</a:t>
-            </a:r>
-            <a:endParaRPr lang="en-US" sz="1600" dirty="0"/>
+              <a:rPr lang="en-US" sz="2000" b="1" dirty="0">
+                <a:solidFill>
+                  <a:srgbClr val="13131A"/>
+                </a:solidFill>
+              </a:rPr>
+              <a:t>Properties</a:t>
+            </a:r>
+            <a:endParaRPr lang="en-US" sz="2000" dirty="0"/>
           </a:p>
           <a:p>
             <a:pPr marL="285750" indent="-285750">
@@ -6305,14 +6285,14 @@
               <a:buChar char="•"/>
             </a:pPr>
             <a:r>
-              <a:rPr lang="en-US" sz="1500" dirty="0">
+              <a:rPr lang="en-US" dirty="0">
                 <a:solidFill>
                   <a:srgbClr val="13131A"/>
                 </a:solidFill>
               </a:rPr>
               <a:t>Convex — the loss surface is one bowl, so any local minimum is the global one</a:t>
             </a:r>
-            <a:endParaRPr lang="en-US" sz="1500" dirty="0"/>
+            <a:endParaRPr lang="en-US" dirty="0"/>
           </a:p>
           <a:p>
             <a:pPr marL="285750" indent="-285750">
@@ -6326,14 +6306,14 @@
               <a:buChar char="•"/>
             </a:pPr>
             <a:r>
-              <a:rPr lang="en-US" sz="1500" dirty="0">
+              <a:rPr lang="en-US" dirty="0">
                 <a:solidFill>
                   <a:srgbClr val="13131A"/>
                 </a:solidFill>
               </a:rPr>
               <a:t>No closed form — there is no normal equation, so we solve numerically</a:t>
             </a:r>
-            <a:endParaRPr lang="en-US" sz="1500" dirty="0"/>
+            <a:endParaRPr lang="en-US" dirty="0"/>
           </a:p>
           <a:p>
             <a:pPr>
@@ -6345,14 +6325,14 @@
               </a:spcAft>
             </a:pPr>
             <a:r>
-              <a:rPr lang="en-US" sz="1500" dirty="0">
+              <a:rPr lang="en-US" dirty="0">
                 <a:solidFill>
                   <a:srgbClr val="13131A"/>
                 </a:solidFill>
               </a:rPr>
               <a:t>Methods: gradient descent, stochastic gradient descent (SGD), Newton’s method.</a:t>
             </a:r>
-            <a:endParaRPr lang="en-US" sz="1500" dirty="0"/>
+            <a:endParaRPr lang="en-US" dirty="0"/>
           </a:p>
           <a:p>
             <a:pPr>
@@ -6364,14 +6344,14 @@
               </a:spcAft>
             </a:pPr>
             <a:r>
-              <a:rPr lang="en-US" sz="1500" dirty="0">
+              <a:rPr lang="en-US" dirty="0">
                 <a:solidFill>
                   <a:srgbClr val="13131A"/>
                 </a:solidFill>
               </a:rPr>
               <a:t>Can add an L1 or L2 penalty to this problem convex while controlling overfitting.</a:t>
             </a:r>
-            <a:endParaRPr lang="en-US" sz="1500" dirty="0"/>
+            <a:endParaRPr lang="en-US" dirty="0"/>
           </a:p>
         </p:txBody>
       </p:sp>
@@ -6424,266 +6404,43 @@
       </p:grpSpPr>
       <p:sp>
         <p:nvSpPr>
-          <p:cNvPr id="2" name="TextBox 1"/>
-          <p:cNvSpPr txBox="1"/>
-          <p:nvPr/>
+          <p:cNvPr id="2" name="Title 1">
+            <a:extLst>
+              <a:ext uri="{FF2B5EF4-FFF2-40B4-BE49-F238E27FC236}">
+                <a16:creationId xmlns:a16="http://schemas.microsoft.com/office/drawing/2014/main" id="{7513127E-D6DF-382F-49A1-1891ADEA51A0}"/>
+              </a:ext>
+            </a:extLst>
+          </p:cNvPr>
+          <p:cNvSpPr>
+            <a:spLocks noGrp="1"/>
+          </p:cNvSpPr>
+          <p:nvPr>
+            <p:ph type="title"/>
+          </p:nvPr>
         </p:nvSpPr>
         <p:spPr>
           <a:xfrm>
-            <a:off x="1981200" y="1029062"/>
-            <a:ext cx="7842147" cy="646331"/>
+            <a:off x="3169515" y="2926080"/>
+            <a:ext cx="10691265" cy="1307592"/>
           </a:xfrm>
-          <a:prstGeom prst="rect">
-            <a:avLst/>
-          </a:prstGeom>
-          <a:noFill/>
         </p:spPr>
         <p:txBody>
-          <a:bodyPr wrap="none">
-            <a:spAutoFit/>
-          </a:bodyPr>
+          <a:bodyPr/>
           <a:lstStyle/>
           <a:p>
-            <a:pPr>
-              <a:defRPr sz="3600" b="1"/>
-            </a:pPr>
-            <a:r>
-              <a:rPr lang="en-US" sz="3600" b="1" cap="all">
-                <a:solidFill>
-                  <a:srgbClr val="13131A"/>
-                </a:solidFill>
-                <a:latin typeface="+mj-lt"/>
-              </a:rPr>
-              <a:t>Optimization II: Gradient Descent</a:t>
-            </a:r>
-          </a:p>
-        </p:txBody>
-      </p:sp>
-      <p:sp>
-        <p:nvSpPr>
-          <p:cNvPr id="4" name="TextBox 3"/>
-          <p:cNvSpPr txBox="1"/>
-          <p:nvPr/>
-        </p:nvSpPr>
-        <p:spPr>
-          <a:xfrm>
-            <a:off x="1981200" y="1950000"/>
-            <a:ext cx="8229600" cy="3616375"/>
-          </a:xfrm>
-          <a:prstGeom prst="rect">
-            <a:avLst/>
-          </a:prstGeom>
-          <a:noFill/>
-        </p:spPr>
-        <p:txBody>
-          <a:bodyPr wrap="square">
-            <a:spAutoFit/>
-          </a:bodyPr>
-          <a:lstStyle/>
-          <a:p>
-            <a:pPr>
-              <a:spcBef>
-                <a:spcPts val="500"/>
-              </a:spcBef>
-              <a:spcAft>
-                <a:spcPts val="500"/>
-              </a:spcAft>
-            </a:pPr>
-            <a:r>
-              <a:rPr lang="en-US" sz="1500" b="1" dirty="0">
-                <a:solidFill>
-                  <a:srgbClr val="13131A"/>
-                </a:solidFill>
-              </a:rPr>
-              <a:t>Gradient of the loss with respect to the weights:</a:t>
-            </a:r>
-            <a:endParaRPr lang="en-US" sz="1500" dirty="0"/>
-          </a:p>
-          <a:p>
-            <a:pPr>
-              <a:spcBef>
-                <a:spcPts val="500"/>
-              </a:spcBef>
-              <a:spcAft>
-                <a:spcPts val="500"/>
-              </a:spcAft>
-            </a:pPr>
-            <a:r>
-              <a:rPr lang="en-US" sz="1700" dirty="0">
-                <a:solidFill>
-                  <a:srgbClr val="13131A"/>
-                </a:solidFill>
-                <a:latin typeface="Cambria Math"/>
-              </a:rPr>
-              <a:t>∂ℒ/∂w = Σᵢ (pᵢ − yᵢ) xᵢ</a:t>
-            </a:r>
-            <a:endParaRPr lang="en-US" sz="1700" dirty="0"/>
-          </a:p>
-          <a:p>
-            <a:pPr>
-              <a:spcBef>
-                <a:spcPts val="500"/>
-              </a:spcBef>
-              <a:spcAft>
-                <a:spcPts val="500"/>
-              </a:spcAft>
-            </a:pPr>
-            <a:r>
-              <a:rPr lang="en-US" sz="1500" dirty="0">
-                <a:solidFill>
-                  <a:srgbClr val="13131A"/>
-                </a:solidFill>
-              </a:rPr>
-              <a:t>Update rule: step downhill, w ← w − η · ∂ℒ/∂w, where η is the learning rate.</a:t>
-            </a:r>
-            <a:endParaRPr lang="en-US" sz="1500" dirty="0"/>
-          </a:p>
-          <a:p>
-            <a:pPr>
-              <a:spcBef>
-                <a:spcPts val="500"/>
-              </a:spcBef>
-              <a:spcAft>
-                <a:spcPts val="500"/>
-              </a:spcAft>
-            </a:pPr>
-            <a:r>
-              <a:rPr lang="en-US" sz="1600" b="1" dirty="0">
-                <a:solidFill>
-                  <a:srgbClr val="13131A"/>
-                </a:solidFill>
-              </a:rPr>
-              <a:t>A direct parallel to linear regression</a:t>
-            </a:r>
-            <a:endParaRPr lang="en-US" sz="1600" dirty="0"/>
-          </a:p>
-          <a:p>
-            <a:pPr marL="285750" indent="-285750">
-              <a:spcBef>
-                <a:spcPts val="500"/>
-              </a:spcBef>
-              <a:spcAft>
-                <a:spcPts val="500"/>
-              </a:spcAft>
-              <a:buFont typeface="Arial" panose="020B0604020202020204" pitchFamily="34" charset="0"/>
-              <a:buChar char="•"/>
-            </a:pPr>
-            <a:r>
-              <a:rPr lang="en-US" sz="1500" dirty="0">
-                <a:solidFill>
-                  <a:srgbClr val="13131A"/>
-                </a:solidFill>
-              </a:rPr>
-              <a:t>Linear regression: updates use residuals (ŷ − y)</a:t>
-            </a:r>
-            <a:endParaRPr lang="en-US" sz="1500" dirty="0"/>
-          </a:p>
-          <a:p>
-            <a:pPr marL="285750" indent="-285750">
-              <a:spcBef>
-                <a:spcPts val="500"/>
-              </a:spcBef>
-              <a:spcAft>
-                <a:spcPts val="500"/>
-              </a:spcAft>
-              <a:buFont typeface="Arial" panose="020B0604020202020204" pitchFamily="34" charset="0"/>
-              <a:buChar char="•"/>
-            </a:pPr>
-            <a:r>
-              <a:rPr lang="en-US" sz="1500" dirty="0">
-                <a:solidFill>
-                  <a:srgbClr val="13131A"/>
-                </a:solidFill>
-              </a:rPr>
-              <a:t>Logistic regression: updates use probabilistic errors (p − y)</a:t>
-            </a:r>
-            <a:endParaRPr lang="en-US" sz="1500" dirty="0"/>
-          </a:p>
-          <a:p>
-            <a:pPr>
-              <a:spcBef>
-                <a:spcPts val="500"/>
-              </a:spcBef>
-              <a:spcAft>
-                <a:spcPts val="500"/>
-              </a:spcAft>
-            </a:pPr>
-            <a:r>
-              <a:rPr lang="en-US" sz="1600" b="1" dirty="0">
-                <a:solidFill>
-                  <a:srgbClr val="13131A"/>
-                </a:solidFill>
-              </a:rPr>
-              <a:t>Interpretation</a:t>
-            </a:r>
-            <a:endParaRPr lang="en-US" sz="1600" dirty="0"/>
-          </a:p>
-          <a:p>
-            <a:pPr marL="285750" indent="-285750">
-              <a:spcBef>
-                <a:spcPts val="500"/>
-              </a:spcBef>
-              <a:spcAft>
-                <a:spcPts val="500"/>
-              </a:spcAft>
-              <a:buFont typeface="Arial" panose="020B0604020202020204" pitchFamily="34" charset="0"/>
-              <a:buChar char="•"/>
-            </a:pPr>
-            <a:r>
-              <a:rPr lang="en-US" sz="1500" dirty="0">
-                <a:solidFill>
-                  <a:srgbClr val="13131A"/>
-                </a:solidFill>
-              </a:rPr>
-              <a:t>p &gt; y: the gradient pushes the prediction down toward 0</a:t>
-            </a:r>
-            <a:endParaRPr lang="en-US" sz="1500" dirty="0"/>
-          </a:p>
-          <a:p>
-            <a:pPr marL="285750" indent="-285750">
-              <a:spcBef>
-                <a:spcPts val="500"/>
-              </a:spcBef>
-              <a:spcAft>
-                <a:spcPts val="500"/>
-              </a:spcAft>
-              <a:buFont typeface="Arial" panose="020B0604020202020204" pitchFamily="34" charset="0"/>
-              <a:buChar char="•"/>
-            </a:pPr>
-            <a:r>
-              <a:rPr lang="en-US" sz="1500" dirty="0">
-                <a:solidFill>
-                  <a:srgbClr val="13131A"/>
-                </a:solidFill>
-              </a:rPr>
-              <a:t>p &lt; y: the gradient pulls the prediction up toward 1</a:t>
-            </a:r>
-            <a:endParaRPr lang="en-US" sz="1500" dirty="0"/>
-          </a:p>
-          <a:p>
-            <a:pPr marL="285750" indent="-285750">
-              <a:spcBef>
-                <a:spcPts val="500"/>
-              </a:spcBef>
-              <a:spcAft>
-                <a:spcPts val="500"/>
-              </a:spcAft>
-              <a:buFont typeface="Arial" panose="020B0604020202020204" pitchFamily="34" charset="0"/>
-              <a:buChar char="•"/>
-            </a:pPr>
-            <a:r>
-              <a:rPr lang="en-US" sz="1500" dirty="0">
-                <a:solidFill>
-                  <a:srgbClr val="13131A"/>
-                </a:solidFill>
-              </a:rPr>
-              <a:t>p ≈ y: the signal is small — that observation is already explained</a:t>
-            </a:r>
-            <a:endParaRPr lang="en-US" sz="1500" dirty="0"/>
+            <a:r>
+              <a:rPr lang="en-US" dirty="0"/>
+              <a:t>Optimization Setup</a:t>
+            </a:r>
           </a:p>
         </p:txBody>
       </p:sp>
     </p:spTree>
+    <p:extLst>
+      <p:ext uri="{BB962C8B-B14F-4D97-AF65-F5344CB8AC3E}">
+        <p14:creationId xmlns:p14="http://schemas.microsoft.com/office/powerpoint/2010/main" val="1748380872"/>
+      </p:ext>
+    </p:extLst>
   </p:cSld>
   <p:clrMapOvr>
     <a:masterClrMapping/>
@@ -6717,7 +6474,7 @@
         <p:spPr>
           <a:xfrm>
             <a:off x="1981200" y="1029062"/>
-            <a:ext cx="9500000" cy="646331"/>
+            <a:ext cx="7842147" cy="646331"/>
           </a:xfrm>
           <a:prstGeom prst="rect">
             <a:avLst/>
@@ -6731,16 +6488,16 @@
           <a:lstStyle/>
           <a:p>
             <a:pPr>
-              <a:defRPr sz="3200" b="1"/>
-            </a:pPr>
-            <a:r>
-              <a:rPr lang="en-US" sz="3200" b="1" cap="all">
+              <a:defRPr sz="3600" b="1"/>
+            </a:pPr>
+            <a:r>
+              <a:rPr lang="en-US" sz="3600" b="1" cap="all">
                 <a:solidFill>
                   <a:srgbClr val="13131A"/>
                 </a:solidFill>
                 <a:latin typeface="+mj-lt"/>
               </a:rPr>
-              <a:t>Part 3 — Using the Model</a:t>
+              <a:t>Optimization II: Gradient Descent</a:t>
             </a:r>
           </a:p>
         </p:txBody>
@@ -6753,8 +6510,8 @@
         </p:nvSpPr>
         <p:spPr>
           <a:xfrm>
-            <a:off x="1981200" y="2100000"/>
-            <a:ext cx="8229600" cy="4083169"/>
+            <a:off x="1981200" y="1950000"/>
+            <a:ext cx="8229600" cy="4262705"/>
           </a:xfrm>
           <a:prstGeom prst="rect">
             <a:avLst/>
@@ -6776,14 +6533,14 @@
               </a:spcAft>
             </a:pPr>
             <a:r>
-              <a:rPr lang="en-US" sz="1800" b="1">
-                <a:solidFill>
-                  <a:srgbClr val="13131A"/>
-                </a:solidFill>
-              </a:rPr>
-              <a:t>From a fitted probability to a decision.</a:t>
-            </a:r>
-            <a:endParaRPr lang="en-US" sz="1800"/>
+              <a:rPr lang="en-US" b="1" dirty="0">
+                <a:solidFill>
+                  <a:srgbClr val="13131A"/>
+                </a:solidFill>
+              </a:rPr>
+              <a:t>Gradient of the loss with respect to the weights:</a:t>
+            </a:r>
+            <a:endParaRPr lang="en-US" dirty="0"/>
           </a:p>
           <a:p>
             <a:pPr>
@@ -6795,14 +6552,15 @@
               </a:spcAft>
             </a:pPr>
             <a:r>
-              <a:rPr lang="en-US" sz="1500">
-                <a:solidFill>
-                  <a:srgbClr val="13131A"/>
-                </a:solidFill>
-              </a:rPr>
-              <a:t>•  How does a probability become a predicted class?</a:t>
-            </a:r>
-            <a:endParaRPr lang="en-US" sz="1500"/>
+              <a:rPr lang="en-US" sz="2000" dirty="0">
+                <a:solidFill>
+                  <a:srgbClr val="13131A"/>
+                </a:solidFill>
+                <a:latin typeface="Cambria Math"/>
+              </a:rPr>
+              <a:t>∂ℒ/∂w = Σᵢ (pᵢ − yᵢ) xᵢ</a:t>
+            </a:r>
+            <a:endParaRPr lang="en-US" sz="2000" dirty="0"/>
           </a:p>
           <a:p>
             <a:pPr>
@@ -6814,14 +6572,14 @@
               </a:spcAft>
             </a:pPr>
             <a:r>
-              <a:rPr lang="en-US" sz="1500">
-                <a:solidFill>
-                  <a:srgbClr val="13131A"/>
-                </a:solidFill>
-              </a:rPr>
-              <a:t>•  Who decides the threshold, and on what grounds?</a:t>
-            </a:r>
-            <a:endParaRPr lang="en-US" sz="1500"/>
+              <a:rPr lang="en-US" dirty="0">
+                <a:solidFill>
+                  <a:srgbClr val="13131A"/>
+                </a:solidFill>
+              </a:rPr>
+              <a:t>Update rule: step downhill, w ← w − η · ∂ℒ/∂w, where η is the learning rate.</a:t>
+            </a:r>
+            <a:endParaRPr lang="en-US" dirty="0"/>
           </a:p>
           <a:p>
             <a:pPr>
@@ -6833,14 +6591,138 @@
               </a:spcAft>
             </a:pPr>
             <a:r>
-              <a:rPr lang="en-US" sz="1500">
-                <a:solidFill>
-                  <a:srgbClr val="13131A"/>
-                </a:solidFill>
-              </a:rPr>
-              <a:t>•  Can you run the whole pipeline yourself?</a:t>
-            </a:r>
-            <a:endParaRPr lang="en-US" sz="1500"/>
+              <a:rPr lang="en-US" sz="2000" b="1" dirty="0">
+                <a:solidFill>
+                  <a:srgbClr val="13131A"/>
+                </a:solidFill>
+              </a:rPr>
+              <a:t>A direct parallel to linear regression</a:t>
+            </a:r>
+            <a:endParaRPr lang="en-US" sz="2000" dirty="0"/>
+          </a:p>
+          <a:p>
+            <a:pPr marL="285750" indent="-285750">
+              <a:spcBef>
+                <a:spcPts val="500"/>
+              </a:spcBef>
+              <a:spcAft>
+                <a:spcPts val="500"/>
+              </a:spcAft>
+              <a:buFont typeface="Arial" panose="020B0604020202020204" pitchFamily="34" charset="0"/>
+              <a:buChar char="•"/>
+            </a:pPr>
+            <a:r>
+              <a:rPr lang="en-US" dirty="0">
+                <a:solidFill>
+                  <a:srgbClr val="13131A"/>
+                </a:solidFill>
+              </a:rPr>
+              <a:t>Linear regression: updates use residuals (ŷ − y)</a:t>
+            </a:r>
+            <a:endParaRPr lang="en-US" dirty="0"/>
+          </a:p>
+          <a:p>
+            <a:pPr marL="285750" indent="-285750">
+              <a:spcBef>
+                <a:spcPts val="500"/>
+              </a:spcBef>
+              <a:spcAft>
+                <a:spcPts val="500"/>
+              </a:spcAft>
+              <a:buFont typeface="Arial" panose="020B0604020202020204" pitchFamily="34" charset="0"/>
+              <a:buChar char="•"/>
+            </a:pPr>
+            <a:r>
+              <a:rPr lang="en-US" dirty="0">
+                <a:solidFill>
+                  <a:srgbClr val="13131A"/>
+                </a:solidFill>
+              </a:rPr>
+              <a:t>Logistic regression: updates use probabilistic errors (p − y)</a:t>
+            </a:r>
+            <a:endParaRPr lang="en-US" dirty="0"/>
+          </a:p>
+          <a:p>
+            <a:pPr>
+              <a:spcBef>
+                <a:spcPts val="500"/>
+              </a:spcBef>
+              <a:spcAft>
+                <a:spcPts val="500"/>
+              </a:spcAft>
+            </a:pPr>
+            <a:r>
+              <a:rPr lang="en-US" sz="2000" b="1" dirty="0">
+                <a:solidFill>
+                  <a:srgbClr val="13131A"/>
+                </a:solidFill>
+              </a:rPr>
+              <a:t>Interpretation</a:t>
+            </a:r>
+            <a:endParaRPr lang="en-US" sz="2000" dirty="0"/>
+          </a:p>
+          <a:p>
+            <a:pPr marL="285750" indent="-285750">
+              <a:spcBef>
+                <a:spcPts val="500"/>
+              </a:spcBef>
+              <a:spcAft>
+                <a:spcPts val="500"/>
+              </a:spcAft>
+              <a:buFont typeface="Arial" panose="020B0604020202020204" pitchFamily="34" charset="0"/>
+              <a:buChar char="•"/>
+            </a:pPr>
+            <a:r>
+              <a:rPr lang="en-US" dirty="0">
+                <a:solidFill>
+                  <a:srgbClr val="13131A"/>
+                </a:solidFill>
+              </a:rPr>
+              <a:t>p &gt; y: the gradient pushes the prediction down toward 0</a:t>
+            </a:r>
+            <a:endParaRPr lang="en-US" dirty="0"/>
+          </a:p>
+          <a:p>
+            <a:pPr marL="285750" indent="-285750">
+              <a:spcBef>
+                <a:spcPts val="500"/>
+              </a:spcBef>
+              <a:spcAft>
+                <a:spcPts val="500"/>
+              </a:spcAft>
+              <a:buFont typeface="Arial" panose="020B0604020202020204" pitchFamily="34" charset="0"/>
+              <a:buChar char="•"/>
+            </a:pPr>
+            <a:r>
+              <a:rPr lang="en-US" dirty="0">
+                <a:solidFill>
+                  <a:srgbClr val="13131A"/>
+                </a:solidFill>
+              </a:rPr>
+              <a:t>p &lt; y: the gradient pulls the prediction up toward 1</a:t>
+            </a:r>
+            <a:endParaRPr lang="en-US" dirty="0"/>
+          </a:p>
+          <a:p>
+            <a:pPr marL="285750" indent="-285750">
+              <a:spcBef>
+                <a:spcPts val="500"/>
+              </a:spcBef>
+              <a:spcAft>
+                <a:spcPts val="500"/>
+              </a:spcAft>
+              <a:buFont typeface="Arial" panose="020B0604020202020204" pitchFamily="34" charset="0"/>
+              <a:buChar char="•"/>
+            </a:pPr>
+            <a:r>
+              <a:rPr lang="en-US" dirty="0">
+                <a:solidFill>
+                  <a:srgbClr val="13131A"/>
+                </a:solidFill>
+              </a:rPr>
+              <a:t>p ≈ y: the signal is small — that observation is already explained</a:t>
+            </a:r>
+            <a:endParaRPr lang="en-US" dirty="0"/>
           </a:p>
         </p:txBody>
       </p:sp>
@@ -6878,7 +6760,7 @@
         <p:spPr>
           <a:xfrm>
             <a:off x="1981200" y="1029062"/>
-            <a:ext cx="7888378" cy="646331"/>
+            <a:ext cx="9500000" cy="646331"/>
           </a:xfrm>
           <a:prstGeom prst="rect">
             <a:avLst/>
@@ -6892,16 +6774,16 @@
           <a:lstStyle/>
           <a:p>
             <a:pPr>
-              <a:defRPr sz="3600" b="1"/>
-            </a:pPr>
-            <a:r>
-              <a:rPr lang="en-US" sz="3600" b="1" cap="all">
+              <a:defRPr sz="3200" b="1"/>
+            </a:pPr>
+            <a:r>
+              <a:rPr lang="en-US" sz="3200" b="1" cap="all">
                 <a:solidFill>
                   <a:srgbClr val="13131A"/>
                 </a:solidFill>
                 <a:latin typeface="+mj-lt"/>
               </a:rPr>
-              <a:t>Classification: The Decision Rule</a:t>
+              <a:t>Part 3 — Using the Model</a:t>
             </a:r>
           </a:p>
         </p:txBody>
@@ -6914,8 +6796,8 @@
         </p:nvSpPr>
         <p:spPr>
           <a:xfrm>
-            <a:off x="1981200" y="1950000"/>
-            <a:ext cx="8229600" cy="3113673"/>
+            <a:off x="1981200" y="2100000"/>
+            <a:ext cx="8229600" cy="4083169"/>
           </a:xfrm>
           <a:prstGeom prst="rect">
             <a:avLst/>
@@ -6937,12 +6819,31 @@
               </a:spcAft>
             </a:pPr>
             <a:r>
+              <a:rPr lang="en-US" sz="1800" b="1">
+                <a:solidFill>
+                  <a:srgbClr val="13131A"/>
+                </a:solidFill>
+              </a:rPr>
+              <a:t>From a fitted probability to a decision.</a:t>
+            </a:r>
+            <a:endParaRPr lang="en-US" sz="1800"/>
+          </a:p>
+          <a:p>
+            <a:pPr>
+              <a:spcBef>
+                <a:spcPts val="500"/>
+              </a:spcBef>
+              <a:spcAft>
+                <a:spcPts val="500"/>
+              </a:spcAft>
+            </a:pPr>
+            <a:r>
               <a:rPr lang="en-US" sz="1500">
                 <a:solidFill>
                   <a:srgbClr val="13131A"/>
                 </a:solidFill>
               </a:rPr>
-              <a:t>Logistic regression outputs probabilities. Classification needs one more ingredient — a decision threshold τ:</a:t>
+              <a:t>•  How does a probability become a predicted class?</a:t>
             </a:r>
             <a:endParaRPr lang="en-US" sz="1500"/>
           </a:p>
@@ -6956,15 +6857,14 @@
               </a:spcAft>
             </a:pPr>
             <a:r>
-              <a:rPr lang="en-US" sz="1700">
-                <a:solidFill>
-                  <a:srgbClr val="13131A"/>
-                </a:solidFill>
-                <a:latin typeface="Cambria Math"/>
-              </a:rPr>
-              <a:t>ŷ = 1 if P(y = 1 | x) ≥ τ,   otherwise ŷ = 0</a:t>
-            </a:r>
-            <a:endParaRPr lang="en-US" sz="1700"/>
+              <a:rPr lang="en-US" sz="1500">
+                <a:solidFill>
+                  <a:srgbClr val="13131A"/>
+                </a:solidFill>
+              </a:rPr>
+              <a:t>•  Who decides the threshold, and on what grounds?</a:t>
+            </a:r>
+            <a:endParaRPr lang="en-US" sz="1500"/>
           </a:p>
           <a:p>
             <a:pPr>
@@ -6981,108 +6881,7 @@
                   <a:srgbClr val="13131A"/>
                 </a:solidFill>
               </a:rPr>
-              <a:t>The standard choice is τ = 0.5, which is equivalent to classifying on the sign of the score z.</a:t>
-            </a:r>
-            <a:endParaRPr lang="en-US" sz="1500"/>
-          </a:p>
-          <a:p>
-            <a:pPr>
-              <a:spcBef>
-                <a:spcPts val="500"/>
-              </a:spcBef>
-              <a:spcAft>
-                <a:spcPts val="500"/>
-              </a:spcAft>
-            </a:pPr>
-            <a:r>
-              <a:rPr lang="en-US" sz="1600" b="1">
-                <a:solidFill>
-                  <a:srgbClr val="13131A"/>
-                </a:solidFill>
-              </a:rPr>
-              <a:t>Why τ = 0.5 is only a default</a:t>
-            </a:r>
-            <a:endParaRPr lang="en-US" sz="1600"/>
-          </a:p>
-          <a:p>
-            <a:pPr marL="285750" indent="-285750">
-              <a:spcBef>
-                <a:spcPts val="500"/>
-              </a:spcBef>
-              <a:spcAft>
-                <a:spcPts val="500"/>
-              </a:spcAft>
-              <a:buFont typeface="Arial" panose="020B0604020202020204" pitchFamily="34" charset="0"/>
-              <a:buChar char="•"/>
-            </a:pPr>
-            <a:r>
-              <a:rPr lang="en-US" sz="1500">
-                <a:solidFill>
-                  <a:srgbClr val="13131A"/>
-                </a:solidFill>
-              </a:rPr>
-              <a:t>It implicitly assumes a false positive and a false negative cost the same.</a:t>
-            </a:r>
-            <a:endParaRPr lang="en-US" sz="1500"/>
-          </a:p>
-          <a:p>
-            <a:pPr marL="285750" indent="-285750">
-              <a:spcBef>
-                <a:spcPts val="500"/>
-              </a:spcBef>
-              <a:spcAft>
-                <a:spcPts val="500"/>
-              </a:spcAft>
-              <a:buFont typeface="Arial" panose="020B0604020202020204" pitchFamily="34" charset="0"/>
-              <a:buChar char="•"/>
-            </a:pPr>
-            <a:r>
-              <a:rPr lang="en-US" sz="1500">
-                <a:solidFill>
-                  <a:srgbClr val="13131A"/>
-                </a:solidFill>
-              </a:rPr>
-              <a:t>Nothing in the fitting procedure chose it — the model never saw τ.</a:t>
-            </a:r>
-            <a:endParaRPr lang="en-US" sz="1500"/>
-          </a:p>
-          <a:p>
-            <a:pPr marL="285750" indent="-285750">
-              <a:spcBef>
-                <a:spcPts val="500"/>
-              </a:spcBef>
-              <a:spcAft>
-                <a:spcPts val="500"/>
-              </a:spcAft>
-              <a:buFont typeface="Arial" panose="020B0604020202020204" pitchFamily="34" charset="0"/>
-              <a:buChar char="•"/>
-            </a:pPr>
-            <a:r>
-              <a:rPr lang="en-US" sz="1500">
-                <a:solidFill>
-                  <a:srgbClr val="13131A"/>
-                </a:solidFill>
-              </a:rPr>
-              <a:t>Changing τ changes the predictions without refitting the model.</a:t>
-            </a:r>
-            <a:endParaRPr lang="en-US" sz="1500"/>
-          </a:p>
-          <a:p>
-            <a:pPr>
-              <a:spcBef>
-                <a:spcPts val="500"/>
-              </a:spcBef>
-              <a:spcAft>
-                <a:spcPts val="500"/>
-              </a:spcAft>
-            </a:pPr>
-            <a:r>
-              <a:rPr lang="en-US" sz="1500" b="1">
-                <a:solidFill>
-                  <a:srgbClr val="13131A"/>
-                </a:solidFill>
-              </a:rPr>
-              <a:t>Next: how to choose τ deliberately.</a:t>
+              <a:t>•  Can you run the whole pipeline yourself?</a:t>
             </a:r>
             <a:endParaRPr lang="en-US" sz="1500"/>
           </a:p>
@@ -7122,7 +6921,7 @@
         <p:spPr>
           <a:xfrm>
             <a:off x="1981200" y="1029062"/>
-            <a:ext cx="9500000" cy="646331"/>
+            <a:ext cx="7888378" cy="646331"/>
           </a:xfrm>
           <a:prstGeom prst="rect">
             <a:avLst/>
@@ -7145,7 +6944,7 @@
                 </a:solidFill>
                 <a:latin typeface="+mj-lt"/>
               </a:rPr>
-              <a:t>Choosing the Threshold</a:t>
+              <a:t>Classification: The Decision Rule</a:t>
             </a:r>
           </a:p>
         </p:txBody>
@@ -7159,7 +6958,7 @@
         <p:spPr>
           <a:xfrm>
             <a:off x="1981200" y="1950000"/>
-            <a:ext cx="8229600" cy="4083169"/>
+            <a:ext cx="8229600" cy="3416320"/>
           </a:xfrm>
           <a:prstGeom prst="rect">
             <a:avLst/>
@@ -7181,14 +6980,72 @@
               </a:spcAft>
             </a:pPr>
             <a:r>
-              <a:rPr lang="en-US" sz="1600" b="1">
-                <a:solidFill>
-                  <a:srgbClr val="13131A"/>
-                </a:solidFill>
-              </a:rPr>
-              <a:t>Set τ from the cost of each error type, not by habit.</a:t>
-            </a:r>
-            <a:endParaRPr lang="en-US" sz="1600"/>
+              <a:rPr lang="en-US" dirty="0">
+                <a:solidFill>
+                  <a:srgbClr val="13131A"/>
+                </a:solidFill>
+              </a:rPr>
+              <a:t>Logistic regression outputs probabilities. Classification needs one more ingredient — a decision threshold τ:</a:t>
+            </a:r>
+            <a:endParaRPr lang="en-US" dirty="0"/>
+          </a:p>
+          <a:p>
+            <a:pPr>
+              <a:spcBef>
+                <a:spcPts val="500"/>
+              </a:spcBef>
+              <a:spcAft>
+                <a:spcPts val="500"/>
+              </a:spcAft>
+            </a:pPr>
+            <a:r>
+              <a:rPr lang="en-US" sz="2000" dirty="0">
+                <a:solidFill>
+                  <a:srgbClr val="13131A"/>
+                </a:solidFill>
+                <a:latin typeface="Cambria Math"/>
+              </a:rPr>
+              <a:t>ŷ = 1 if P(y = 1 | x) ≥ τ,   otherwise ŷ = 0</a:t>
+            </a:r>
+            <a:endParaRPr lang="en-US" sz="2000" dirty="0"/>
+          </a:p>
+          <a:p>
+            <a:pPr>
+              <a:spcBef>
+                <a:spcPts val="500"/>
+              </a:spcBef>
+              <a:spcAft>
+                <a:spcPts val="500"/>
+              </a:spcAft>
+            </a:pPr>
+            <a:r>
+              <a:rPr lang="en-US" dirty="0">
+                <a:solidFill>
+                  <a:srgbClr val="13131A"/>
+                </a:solidFill>
+              </a:rPr>
+              <a:t>The standard choice is τ = 0.5, which is equivalent to classifying on the sign of the score z.</a:t>
+            </a:r>
+            <a:endParaRPr lang="en-US" dirty="0"/>
+          </a:p>
+          <a:p>
+            <a:pPr>
+              <a:spcBef>
+                <a:spcPts val="500"/>
+              </a:spcBef>
+              <a:spcAft>
+                <a:spcPts val="500"/>
+              </a:spcAft>
+            </a:pPr>
+            <a:r>
+              <a:rPr lang="en-US" sz="2000" b="1" dirty="0">
+                <a:solidFill>
+                  <a:srgbClr val="13131A"/>
+                </a:solidFill>
+              </a:rPr>
+              <a:t>Why τ = 0.5 is only a default</a:t>
+            </a:r>
+            <a:endParaRPr lang="en-US" sz="2000" dirty="0"/>
           </a:p>
           <a:p>
             <a:pPr marL="285750" indent="-285750">
@@ -7202,14 +7059,14 @@
               <a:buChar char="•"/>
             </a:pPr>
             <a:r>
-              <a:rPr lang="en-US" sz="1500">
-                <a:solidFill>
-                  <a:srgbClr val="13131A"/>
-                </a:solidFill>
-              </a:rPr>
-              <a:t>Medical screening: a missed case (false negative) is far costlier than a false alarm, so lower τ — catch more positives and accept more false positives</a:t>
-            </a:r>
-            <a:endParaRPr lang="en-US" sz="1500"/>
+              <a:rPr lang="en-US" dirty="0">
+                <a:solidFill>
+                  <a:srgbClr val="13131A"/>
+                </a:solidFill>
+              </a:rPr>
+              <a:t>It implicitly assumes a false positive and a false negative cost the same.</a:t>
+            </a:r>
+            <a:endParaRPr lang="en-US" dirty="0"/>
           </a:p>
           <a:p>
             <a:pPr marL="285750" indent="-285750">
@@ -7223,14 +7080,14 @@
               <a:buChar char="•"/>
             </a:pPr>
             <a:r>
-              <a:rPr lang="en-US" sz="1500">
-                <a:solidFill>
-                  <a:srgbClr val="13131A"/>
-                </a:solidFill>
-              </a:rPr>
-              <a:t>Fraud review: each flag costs analyst time, so raise τ to protect precision</a:t>
-            </a:r>
-            <a:endParaRPr lang="en-US" sz="1500"/>
+              <a:rPr lang="en-US" dirty="0">
+                <a:solidFill>
+                  <a:srgbClr val="13131A"/>
+                </a:solidFill>
+              </a:rPr>
+              <a:t>Nothing in the fitting procedure chose it — the model never saw τ.</a:t>
+            </a:r>
+            <a:endParaRPr lang="en-US" dirty="0"/>
           </a:p>
           <a:p>
             <a:pPr marL="285750" indent="-285750">
@@ -7244,71 +7101,14 @@
               <a:buChar char="•"/>
             </a:pPr>
             <a:r>
-              <a:rPr lang="en-US" sz="1500">
-                <a:solidFill>
-                  <a:srgbClr val="13131A"/>
-                </a:solidFill>
-              </a:rPr>
-              <a:t>Credit default: a lender who loses more on a bad loan than on a declined application should lower τ</a:t>
-            </a:r>
-            <a:endParaRPr lang="en-US" sz="1500"/>
-          </a:p>
-          <a:p>
-            <a:pPr>
-              <a:spcBef>
-                <a:spcPts val="500"/>
-              </a:spcBef>
-              <a:spcAft>
-                <a:spcPts val="500"/>
-              </a:spcAft>
-            </a:pPr>
-            <a:r>
-              <a:rPr lang="en-US" sz="1600" b="1">
-                <a:solidFill>
-                  <a:srgbClr val="13131A"/>
-                </a:solidFill>
-              </a:rPr>
-              <a:t>Two vocabulary terms</a:t>
-            </a:r>
-            <a:endParaRPr lang="en-US" sz="1600"/>
-          </a:p>
-          <a:p>
-            <a:pPr>
-              <a:spcBef>
-                <a:spcPts val="500"/>
-              </a:spcBef>
-              <a:spcAft>
-                <a:spcPts val="500"/>
-              </a:spcAft>
-            </a:pPr>
-            <a:r>
-              <a:rPr lang="en-US" sz="1500">
-                <a:solidFill>
-                  <a:srgbClr val="13131A"/>
-                </a:solidFill>
-              </a:rPr>
-              <a:t>False positive: predicted 1, actually 0.   False negative: predicted 0, actually 1.</a:t>
-            </a:r>
-            <a:endParaRPr lang="en-US" sz="1500"/>
-          </a:p>
-          <a:p>
-            <a:pPr>
-              <a:spcBef>
-                <a:spcPts val="500"/>
-              </a:spcBef>
-              <a:spcAft>
-                <a:spcPts val="500"/>
-              </a:spcAft>
-            </a:pPr>
-            <a:r>
-              <a:rPr lang="en-US" sz="1500">
-                <a:solidFill>
-                  <a:srgbClr val="13131A"/>
-                </a:solidFill>
-              </a:rPr>
-              <a:t>Sweeping τ from 0 to 1 traces the ROC and precision–recall curves — the subject of the next lecture.</a:t>
-            </a:r>
-            <a:endParaRPr lang="en-US" sz="1500"/>
+              <a:rPr lang="en-US" dirty="0">
+                <a:solidFill>
+                  <a:srgbClr val="13131A"/>
+                </a:solidFill>
+              </a:rPr>
+              <a:t>Changing τ changes the predictions without refitting the model.</a:t>
+            </a:r>
+            <a:endParaRPr lang="en-US" dirty="0"/>
           </a:p>
         </p:txBody>
       </p:sp>
@@ -7346,7 +7146,7 @@
         <p:spPr>
           <a:xfrm>
             <a:off x="1981200" y="1029062"/>
-            <a:ext cx="6621941" cy="646331"/>
+            <a:ext cx="9500000" cy="646331"/>
           </a:xfrm>
           <a:prstGeom prst="rect">
             <a:avLst/>
@@ -7369,7 +7169,7 @@
                 </a:solidFill>
                 <a:latin typeface="+mj-lt"/>
               </a:rPr>
-              <a:t>Check Your Understanding</a:t>
+              <a:t>Choosing the Threshold</a:t>
             </a:r>
           </a:p>
         </p:txBody>
@@ -7383,7 +7183,7 @@
         <p:spPr>
           <a:xfrm>
             <a:off x="1981200" y="1950000"/>
-            <a:ext cx="8229600" cy="3390672"/>
+            <a:ext cx="8229600" cy="3693319"/>
           </a:xfrm>
           <a:prstGeom prst="rect">
             <a:avLst/>
@@ -7405,14 +7205,77 @@
               </a:spcAft>
             </a:pPr>
             <a:r>
-              <a:rPr lang="en-US" sz="1500">
-                <a:solidFill>
-                  <a:srgbClr val="13131A"/>
-                </a:solidFill>
-              </a:rPr>
-              <a:t>A model fit to the Default data (balance in $1,000s) gives w = 2.0, b = −7.0. For a customer with a $2,000 balance (x = 2.0), work out the predicted probability and the class label.</a:t>
-            </a:r>
-            <a:endParaRPr lang="en-US" sz="1500"/>
+              <a:rPr lang="en-US" sz="2000" b="1" dirty="0">
+                <a:solidFill>
+                  <a:srgbClr val="13131A"/>
+                </a:solidFill>
+              </a:rPr>
+              <a:t>Set τ from the cost of each error type, not by habit.</a:t>
+            </a:r>
+            <a:endParaRPr lang="en-US" sz="2000" dirty="0"/>
+          </a:p>
+          <a:p>
+            <a:pPr marL="285750" indent="-285750">
+              <a:spcBef>
+                <a:spcPts val="500"/>
+              </a:spcBef>
+              <a:spcAft>
+                <a:spcPts val="500"/>
+              </a:spcAft>
+              <a:buFont typeface="Arial" panose="020B0604020202020204" pitchFamily="34" charset="0"/>
+              <a:buChar char="•"/>
+            </a:pPr>
+            <a:r>
+              <a:rPr lang="en-US" dirty="0">
+                <a:solidFill>
+                  <a:srgbClr val="13131A"/>
+                </a:solidFill>
+              </a:rPr>
+              <a:t>Medical screening: a missed case (false negative) is far costlier than a false alarm, so lower τ — catch more positives and accept more false positives</a:t>
+            </a:r>
+            <a:endParaRPr lang="en-US" dirty="0"/>
+          </a:p>
+          <a:p>
+            <a:pPr marL="285750" indent="-285750">
+              <a:spcBef>
+                <a:spcPts val="500"/>
+              </a:spcBef>
+              <a:spcAft>
+                <a:spcPts val="500"/>
+              </a:spcAft>
+              <a:buFont typeface="Arial" panose="020B0604020202020204" pitchFamily="34" charset="0"/>
+              <a:buChar char="•"/>
+            </a:pPr>
+            <a:r>
+              <a:rPr lang="en-US" dirty="0">
+                <a:solidFill>
+                  <a:srgbClr val="13131A"/>
+                </a:solidFill>
+              </a:rPr>
+              <a:t>Fraud review: each flag costs analyst time, so raise τ to protect precision</a:t>
+            </a:r>
+            <a:endParaRPr lang="en-US" dirty="0"/>
+          </a:p>
+          <a:p>
+            <a:pPr marL="285750" indent="-285750">
+              <a:spcBef>
+                <a:spcPts val="500"/>
+              </a:spcBef>
+              <a:spcAft>
+                <a:spcPts val="500"/>
+              </a:spcAft>
+              <a:buFont typeface="Arial" panose="020B0604020202020204" pitchFamily="34" charset="0"/>
+              <a:buChar char="•"/>
+            </a:pPr>
+            <a:r>
+              <a:rPr lang="en-US" dirty="0">
+                <a:solidFill>
+                  <a:srgbClr val="13131A"/>
+                </a:solidFill>
+              </a:rPr>
+              <a:t>Credit default: a lender who loses more on a bad loan than on a declined application should lower τ</a:t>
+            </a:r>
+            <a:endParaRPr lang="en-US" dirty="0"/>
           </a:p>
           <a:p>
             <a:pPr>
@@ -7424,14 +7287,14 @@
               </a:spcAft>
             </a:pPr>
             <a:r>
-              <a:rPr lang="en-US" sz="1500" b="1">
-                <a:solidFill>
-                  <a:srgbClr val="13131A"/>
-                </a:solidFill>
-              </a:rPr>
-              <a:t>Step 1 — compute the score</a:t>
-            </a:r>
-            <a:endParaRPr lang="en-US" sz="1500"/>
+              <a:rPr lang="en-US" sz="2000" b="1" dirty="0">
+                <a:solidFill>
+                  <a:srgbClr val="13131A"/>
+                </a:solidFill>
+              </a:rPr>
+              <a:t>Types of mistakes</a:t>
+            </a:r>
+            <a:endParaRPr lang="en-US" sz="2000" dirty="0"/>
           </a:p>
           <a:p>
             <a:pPr>
@@ -7443,15 +7306,14 @@
               </a:spcAft>
             </a:pPr>
             <a:r>
-              <a:rPr lang="en-US" sz="1700">
-                <a:solidFill>
-                  <a:srgbClr val="13131A"/>
-                </a:solidFill>
-                <a:latin typeface="Cambria Math"/>
-              </a:rPr>
-              <a:t>z = wᵀx + b = 2.0(2.0) − 7.0 = −3.0</a:t>
-            </a:r>
-            <a:endParaRPr lang="en-US" sz="1700"/>
+              <a:rPr lang="en-US" dirty="0">
+                <a:solidFill>
+                  <a:srgbClr val="13131A"/>
+                </a:solidFill>
+              </a:rPr>
+              <a:t>False positive: predicted 1, actually 0.   False negative: predicted 0, actually 1.</a:t>
+            </a:r>
+            <a:endParaRPr lang="en-US" dirty="0"/>
           </a:p>
           <a:p>
             <a:pPr>
@@ -7463,92 +7325,14 @@
               </a:spcAft>
             </a:pPr>
             <a:r>
-              <a:rPr lang="en-US" sz="1500" b="1">
-                <a:solidFill>
-                  <a:srgbClr val="13131A"/>
-                </a:solidFill>
-              </a:rPr>
-              <a:t>Step 2 — convert the score to a probability</a:t>
-            </a:r>
-            <a:endParaRPr lang="en-US" sz="1500"/>
-          </a:p>
-          <a:p>
-            <a:pPr>
-              <a:spcBef>
-                <a:spcPts val="500"/>
-              </a:spcBef>
-              <a:spcAft>
-                <a:spcPts val="500"/>
-              </a:spcAft>
-            </a:pPr>
-            <a:r>
-              <a:rPr lang="en-US" sz="1700">
-                <a:solidFill>
-                  <a:srgbClr val="13131A"/>
-                </a:solidFill>
-                <a:latin typeface="Cambria Math"/>
-              </a:rPr>
-              <a:t>p = σ(−3.0) = 1 / (1 + exp(3.0)) ≈ 0.047</a:t>
-            </a:r>
-            <a:endParaRPr lang="en-US" sz="1700"/>
-          </a:p>
-          <a:p>
-            <a:pPr>
-              <a:spcBef>
-                <a:spcPts val="500"/>
-              </a:spcBef>
-              <a:spcAft>
-                <a:spcPts val="500"/>
-              </a:spcAft>
-            </a:pPr>
-            <a:r>
-              <a:rPr lang="en-US" sz="1500" b="1">
-                <a:solidFill>
-                  <a:srgbClr val="13131A"/>
-                </a:solidFill>
-              </a:rPr>
-              <a:t>Step 3 — apply the decision rule</a:t>
-            </a:r>
-            <a:endParaRPr lang="en-US" sz="1500"/>
-          </a:p>
-          <a:p>
-            <a:pPr>
-              <a:spcBef>
-                <a:spcPts val="500"/>
-              </a:spcBef>
-              <a:spcAft>
-                <a:spcPts val="500"/>
-              </a:spcAft>
-            </a:pPr>
-            <a:r>
-              <a:rPr lang="en-US" sz="1700">
-                <a:solidFill>
-                  <a:srgbClr val="13131A"/>
-                </a:solidFill>
-                <a:latin typeface="Cambria Math"/>
-              </a:rPr>
-              <a:t>p = 0.047 &lt; τ = 0.5  ⇒  predict ŷ = 0 (no default)</a:t>
-            </a:r>
-            <a:endParaRPr lang="en-US" sz="1700"/>
-          </a:p>
-          <a:p>
-            <a:pPr>
-              <a:spcBef>
-                <a:spcPts val="500"/>
-              </a:spcBef>
-              <a:spcAft>
-                <a:spcPts val="500"/>
-              </a:spcAft>
-            </a:pPr>
-            <a:r>
-              <a:rPr lang="en-US" sz="1500" b="1">
-                <a:solidFill>
-                  <a:srgbClr val="13131A"/>
-                </a:solidFill>
-              </a:rPr>
-              <a:t>Now try it yourself: what is the predicted class at a $4,000 balance, and what threshold would flip the $2,000 answer?</a:t>
-            </a:r>
-            <a:endParaRPr lang="en-US" sz="1500"/>
+              <a:rPr lang="en-US" dirty="0">
+                <a:solidFill>
+                  <a:srgbClr val="13131A"/>
+                </a:solidFill>
+              </a:rPr>
+              <a:t>Sweeping τ from 0 to 1 traces the ROC and precision–recall curves — the subject of the next lecture.</a:t>
+            </a:r>
+            <a:endParaRPr lang="en-US" dirty="0"/>
           </a:p>
         </p:txBody>
       </p:sp>
@@ -7586,7 +7370,7 @@
         <p:spPr>
           <a:xfrm>
             <a:off x="1981200" y="1029062"/>
-            <a:ext cx="9500000" cy="646331"/>
+            <a:ext cx="6621941" cy="646331"/>
           </a:xfrm>
           <a:prstGeom prst="rect">
             <a:avLst/>
@@ -7603,13 +7387,13 @@
               <a:defRPr sz="3600" b="1"/>
             </a:pPr>
             <a:r>
-              <a:rPr lang="en-US" sz="3600" b="1" cap="all">
+              <a:rPr lang="en-US" sz="3600" b="1" cap="all" dirty="0">
                 <a:solidFill>
                   <a:srgbClr val="13131A"/>
                 </a:solidFill>
                 <a:latin typeface="+mj-lt"/>
               </a:rPr>
-              <a:t>Conceptual Summary</a:t>
+              <a:t>Check Your Understanding</a:t>
             </a:r>
           </a:p>
         </p:txBody>
@@ -7623,7 +7407,7 @@
         <p:spPr>
           <a:xfrm>
             <a:off x="1981200" y="1950000"/>
-            <a:ext cx="8229600" cy="4083169"/>
+            <a:ext cx="8229600" cy="3544560"/>
           </a:xfrm>
           <a:prstGeom prst="rect">
             <a:avLst/>
@@ -7645,14 +7429,14 @@
               </a:spcAft>
             </a:pPr>
             <a:r>
-              <a:rPr lang="en-US" sz="1500">
-                <a:solidFill>
-                  <a:srgbClr val="13131A"/>
-                </a:solidFill>
-              </a:rPr>
-              <a:t>1.  Start with the linear regression structure: z = wᵀx + b</a:t>
-            </a:r>
-            <a:endParaRPr lang="en-US" sz="1500"/>
+              <a:rPr lang="en-US" sz="1600" dirty="0">
+                <a:solidFill>
+                  <a:srgbClr val="13131A"/>
+                </a:solidFill>
+              </a:rPr>
+              <a:t>A model fit to the Default data (balance in $1,000s) gives w = 2.0, b = −7.0. For a customer with a $2,000 balance (x = 2.0), work out the predicted probability and the class label.</a:t>
+            </a:r>
+            <a:endParaRPr lang="en-US" sz="1600" dirty="0"/>
           </a:p>
           <a:p>
             <a:pPr>
@@ -7664,14 +7448,14 @@
               </a:spcAft>
             </a:pPr>
             <a:r>
-              <a:rPr lang="en-US" sz="1500">
-                <a:solidFill>
-                  <a:srgbClr val="13131A"/>
-                </a:solidFill>
-              </a:rPr>
-              <a:t>2.  Interpret z as the log-odds (logit) of the outcome</a:t>
-            </a:r>
-            <a:endParaRPr lang="en-US" sz="1500"/>
+              <a:rPr lang="en-US" sz="1600" b="1" dirty="0">
+                <a:solidFill>
+                  <a:srgbClr val="13131A"/>
+                </a:solidFill>
+              </a:rPr>
+              <a:t>Step 1 — compute the score</a:t>
+            </a:r>
+            <a:endParaRPr lang="en-US" sz="1600" dirty="0"/>
           </a:p>
           <a:p>
             <a:pPr>
@@ -7683,14 +7467,33 @@
               </a:spcAft>
             </a:pPr>
             <a:r>
-              <a:rPr lang="en-US" sz="1500">
-                <a:solidFill>
-                  <a:srgbClr val="13131A"/>
-                </a:solidFill>
-              </a:rPr>
-              <a:t>3.  Apply the sigmoid to turn the score into a probability</a:t>
-            </a:r>
-            <a:endParaRPr lang="en-US" sz="1500"/>
+              <a:rPr lang="en-US" dirty="0">
+                <a:solidFill>
+                  <a:srgbClr val="13131A"/>
+                </a:solidFill>
+                <a:latin typeface="Cambria Math"/>
+              </a:rPr>
+              <a:t>z = </a:t>
+            </a:r>
+            <a:r>
+              <a:rPr lang="en-US" dirty="0" err="1">
+                <a:solidFill>
+                  <a:srgbClr val="13131A"/>
+                </a:solidFill>
+                <a:latin typeface="Cambria Math"/>
+              </a:rPr>
+              <a:t>wᵀx</a:t>
+            </a:r>
+            <a:r>
+              <a:rPr lang="en-US" dirty="0">
+                <a:solidFill>
+                  <a:srgbClr val="13131A"/>
+                </a:solidFill>
+                <a:latin typeface="Cambria Math"/>
+              </a:rPr>
+              <a:t> + b = 2.0(2.0) − 7.0 = −3.0</a:t>
+            </a:r>
+            <a:endParaRPr lang="en-US" dirty="0"/>
           </a:p>
           <a:p>
             <a:pPr>
@@ -7702,14 +7505,14 @@
               </a:spcAft>
             </a:pPr>
             <a:r>
-              <a:rPr lang="en-US" sz="1500">
-                <a:solidFill>
-                  <a:srgbClr val="13131A"/>
-                </a:solidFill>
-              </a:rPr>
-              <a:t>4.  Model the outcome with a Bernoulli likelihood</a:t>
-            </a:r>
-            <a:endParaRPr lang="en-US" sz="1500"/>
+              <a:rPr lang="en-US" sz="1600" b="1" dirty="0">
+                <a:solidFill>
+                  <a:srgbClr val="13131A"/>
+                </a:solidFill>
+              </a:rPr>
+              <a:t>Step 2 — convert the score to a probability</a:t>
+            </a:r>
+            <a:endParaRPr lang="en-US" sz="1600" dirty="0"/>
           </a:p>
           <a:p>
             <a:pPr>
@@ -7721,14 +7524,15 @@
               </a:spcAft>
             </a:pPr>
             <a:r>
-              <a:rPr lang="en-US" sz="1500">
-                <a:solidFill>
-                  <a:srgbClr val="13131A"/>
-                </a:solidFill>
-              </a:rPr>
-              <a:t>5.  Minimize the cross-entropy loss (convex, no closed form)</a:t>
-            </a:r>
-            <a:endParaRPr lang="en-US" sz="1500"/>
+              <a:rPr lang="en-US" dirty="0">
+                <a:solidFill>
+                  <a:srgbClr val="13131A"/>
+                </a:solidFill>
+                <a:latin typeface="Cambria Math"/>
+              </a:rPr>
+              <a:t>p = σ(−3.0) = 1 / (1 + exp(3.0)) ≈ 0.047</a:t>
+            </a:r>
+            <a:endParaRPr lang="en-US" dirty="0"/>
           </a:p>
           <a:p>
             <a:pPr>
@@ -7740,14 +7544,14 @@
               </a:spcAft>
             </a:pPr>
             <a:r>
-              <a:rPr lang="en-US" sz="1500">
-                <a:solidFill>
-                  <a:srgbClr val="13131A"/>
-                </a:solidFill>
-              </a:rPr>
-              <a:t>6.  Solve with gradient-based optimization</a:t>
-            </a:r>
-            <a:endParaRPr lang="en-US" sz="1500"/>
+              <a:rPr lang="en-US" sz="1600" b="1" dirty="0">
+                <a:solidFill>
+                  <a:srgbClr val="13131A"/>
+                </a:solidFill>
+              </a:rPr>
+              <a:t>Step 3 — apply the decision rule</a:t>
+            </a:r>
+            <a:endParaRPr lang="en-US" sz="1600" dirty="0"/>
           </a:p>
           <a:p>
             <a:pPr>
@@ -7759,14 +7563,15 @@
               </a:spcAft>
             </a:pPr>
             <a:r>
-              <a:rPr lang="en-US" sz="1500">
-                <a:solidFill>
-                  <a:srgbClr val="13131A"/>
-                </a:solidFill>
-              </a:rPr>
-              <a:t>7.  Apply a threshold τ to turn probabilities into class decisions</a:t>
-            </a:r>
-            <a:endParaRPr lang="en-US" sz="1500"/>
+              <a:rPr lang="en-US" dirty="0">
+                <a:solidFill>
+                  <a:srgbClr val="13131A"/>
+                </a:solidFill>
+                <a:latin typeface="Cambria Math"/>
+              </a:rPr>
+              <a:t>p = 0.047 &lt; τ = 0.5  ⇒  predict ŷ = 0 (no default)</a:t>
+            </a:r>
+            <a:endParaRPr lang="en-US" dirty="0"/>
           </a:p>
           <a:p>
             <a:pPr>
@@ -7778,77 +7583,14 @@
               </a:spcAft>
             </a:pPr>
             <a:r>
-              <a:rPr lang="en-US" sz="1600" b="1">
-                <a:solidFill>
-                  <a:srgbClr val="13131A"/>
-                </a:solidFill>
-              </a:rPr>
-              <a:t>You should now be able to</a:t>
-            </a:r>
-            <a:endParaRPr lang="en-US" sz="1600"/>
-          </a:p>
-          <a:p>
-            <a:pPr marL="285750" indent="-285750">
-              <a:spcBef>
-                <a:spcPts val="500"/>
-              </a:spcBef>
-              <a:spcAft>
-                <a:spcPts val="500"/>
-              </a:spcAft>
-              <a:buFont typeface="Arial" panose="020B0604020202020204" pitchFamily="34" charset="0"/>
-              <a:buChar char="•"/>
-            </a:pPr>
-            <a:r>
-              <a:rPr lang="en-US" sz="1500">
-                <a:solidFill>
-                  <a:srgbClr val="13131A"/>
-                </a:solidFill>
-              </a:rPr>
-              <a:t>Compute a predicted probability from w, b, and x by hand</a:t>
-            </a:r>
-            <a:endParaRPr lang="en-US" sz="1500"/>
-          </a:p>
-          <a:p>
-            <a:pPr marL="285750" indent="-285750">
-              <a:spcBef>
-                <a:spcPts val="500"/>
-              </a:spcBef>
-              <a:spcAft>
-                <a:spcPts val="500"/>
-              </a:spcAft>
-              <a:buFont typeface="Arial" panose="020B0604020202020204" pitchFamily="34" charset="0"/>
-              <a:buChar char="•"/>
-            </a:pPr>
-            <a:r>
-              <a:rPr lang="en-US" sz="1500">
-                <a:solidFill>
-                  <a:srgbClr val="13131A"/>
-                </a:solidFill>
-              </a:rPr>
-              <a:t>Interpret any coefficient as an odds ratio, and say why it is not a probability change</a:t>
-            </a:r>
-            <a:endParaRPr lang="en-US" sz="1500"/>
-          </a:p>
-          <a:p>
-            <a:pPr marL="285750" indent="-285750">
-              <a:spcBef>
-                <a:spcPts val="500"/>
-              </a:spcBef>
-              <a:spcAft>
-                <a:spcPts val="500"/>
-              </a:spcAft>
-              <a:buFont typeface="Arial" panose="020B0604020202020204" pitchFamily="34" charset="0"/>
-              <a:buChar char="•"/>
-            </a:pPr>
-            <a:r>
-              <a:rPr lang="en-US" sz="1500">
-                <a:solidFill>
-                  <a:srgbClr val="13131A"/>
-                </a:solidFill>
-              </a:rPr>
-              <a:t>Justify a threshold from the relative cost of the two error types</a:t>
-            </a:r>
-            <a:endParaRPr lang="en-US" sz="1500"/>
+              <a:rPr lang="en-US" sz="1600" b="1" dirty="0">
+                <a:solidFill>
+                  <a:srgbClr val="13131A"/>
+                </a:solidFill>
+              </a:rPr>
+              <a:t>Now try it yourself: what is the predicted class at a $4,000 balance, and what threshold would flip the $2,000 answer?</a:t>
+            </a:r>
+            <a:endParaRPr lang="en-US" sz="1600" dirty="0"/>
           </a:p>
         </p:txBody>
       </p:sp>
@@ -7903,13 +7645,13 @@
               <a:defRPr sz="3600" b="1"/>
             </a:pPr>
             <a:r>
-              <a:rPr lang="en-US" sz="3600" b="1" cap="all">
+              <a:rPr lang="en-US" sz="3600" b="1" cap="all" dirty="0">
                 <a:solidFill>
                   <a:srgbClr val="13131A"/>
                 </a:solidFill>
                 <a:latin typeface="+mj-lt"/>
               </a:rPr>
-              <a:t>Where We Go Next</a:t>
+              <a:t>Conceptual Summary</a:t>
             </a:r>
           </a:p>
         </p:txBody>
@@ -7923,7 +7665,7 @@
         <p:spPr>
           <a:xfrm>
             <a:off x="1981200" y="1950000"/>
-            <a:ext cx="8229600" cy="3488134"/>
+            <a:ext cx="8229600" cy="4083169"/>
           </a:xfrm>
           <a:prstGeom prst="rect">
             <a:avLst/>
@@ -7945,14 +7687,163 @@
               </a:spcAft>
             </a:pPr>
             <a:r>
-              <a:rPr lang="en-US" sz="1600" b="1">
-                <a:solidFill>
-                  <a:srgbClr val="13131A"/>
-                </a:solidFill>
-              </a:rPr>
-              <a:t>Beyond two classes</a:t>
-            </a:r>
-            <a:endParaRPr lang="en-US" sz="1600"/>
+              <a:rPr lang="en-US" sz="1600" dirty="0">
+                <a:solidFill>
+                  <a:srgbClr val="13131A"/>
+                </a:solidFill>
+              </a:rPr>
+              <a:t>1.  Start with the linear regression structure: z = </a:t>
+            </a:r>
+            <a:r>
+              <a:rPr lang="en-US" sz="1600" dirty="0" err="1">
+                <a:solidFill>
+                  <a:srgbClr val="13131A"/>
+                </a:solidFill>
+              </a:rPr>
+              <a:t>wᵀx</a:t>
+            </a:r>
+            <a:r>
+              <a:rPr lang="en-US" sz="1600" dirty="0">
+                <a:solidFill>
+                  <a:srgbClr val="13131A"/>
+                </a:solidFill>
+              </a:rPr>
+              <a:t> + b</a:t>
+            </a:r>
+            <a:endParaRPr lang="en-US" sz="1600" dirty="0"/>
+          </a:p>
+          <a:p>
+            <a:pPr>
+              <a:spcBef>
+                <a:spcPts val="500"/>
+              </a:spcBef>
+              <a:spcAft>
+                <a:spcPts val="500"/>
+              </a:spcAft>
+            </a:pPr>
+            <a:r>
+              <a:rPr lang="en-US" sz="1600" dirty="0">
+                <a:solidFill>
+                  <a:srgbClr val="13131A"/>
+                </a:solidFill>
+              </a:rPr>
+              <a:t>2.  Interpret z as the log-odds (logit) of the outcome</a:t>
+            </a:r>
+            <a:endParaRPr lang="en-US" sz="1600" dirty="0"/>
+          </a:p>
+          <a:p>
+            <a:pPr>
+              <a:spcBef>
+                <a:spcPts val="500"/>
+              </a:spcBef>
+              <a:spcAft>
+                <a:spcPts val="500"/>
+              </a:spcAft>
+            </a:pPr>
+            <a:r>
+              <a:rPr lang="en-US" sz="1600" dirty="0">
+                <a:solidFill>
+                  <a:srgbClr val="13131A"/>
+                </a:solidFill>
+              </a:rPr>
+              <a:t>3.  Apply the sigmoid to turn the score into a probability</a:t>
+            </a:r>
+            <a:endParaRPr lang="en-US" sz="1600" dirty="0"/>
+          </a:p>
+          <a:p>
+            <a:pPr>
+              <a:spcBef>
+                <a:spcPts val="500"/>
+              </a:spcBef>
+              <a:spcAft>
+                <a:spcPts val="500"/>
+              </a:spcAft>
+            </a:pPr>
+            <a:r>
+              <a:rPr lang="en-US" sz="1600" dirty="0">
+                <a:solidFill>
+                  <a:srgbClr val="13131A"/>
+                </a:solidFill>
+              </a:rPr>
+              <a:t>4.  Model the outcome with a Bernoulli likelihood</a:t>
+            </a:r>
+            <a:endParaRPr lang="en-US" sz="1600" dirty="0"/>
+          </a:p>
+          <a:p>
+            <a:pPr>
+              <a:spcBef>
+                <a:spcPts val="500"/>
+              </a:spcBef>
+              <a:spcAft>
+                <a:spcPts val="500"/>
+              </a:spcAft>
+            </a:pPr>
+            <a:r>
+              <a:rPr lang="en-US" sz="1600" dirty="0">
+                <a:solidFill>
+                  <a:srgbClr val="13131A"/>
+                </a:solidFill>
+              </a:rPr>
+              <a:t>5.  Minimize the cross-entropy loss (convex, no closed form)</a:t>
+            </a:r>
+            <a:endParaRPr lang="en-US" sz="1600" dirty="0"/>
+          </a:p>
+          <a:p>
+            <a:pPr>
+              <a:spcBef>
+                <a:spcPts val="500"/>
+              </a:spcBef>
+              <a:spcAft>
+                <a:spcPts val="500"/>
+              </a:spcAft>
+            </a:pPr>
+            <a:r>
+              <a:rPr lang="en-US" sz="1600" dirty="0">
+                <a:solidFill>
+                  <a:srgbClr val="13131A"/>
+                </a:solidFill>
+              </a:rPr>
+              <a:t>6.  Solve with gradient-based optimization</a:t>
+            </a:r>
+            <a:endParaRPr lang="en-US" sz="1600" dirty="0"/>
+          </a:p>
+          <a:p>
+            <a:pPr>
+              <a:spcBef>
+                <a:spcPts val="500"/>
+              </a:spcBef>
+              <a:spcAft>
+                <a:spcPts val="500"/>
+              </a:spcAft>
+            </a:pPr>
+            <a:r>
+              <a:rPr lang="en-US" sz="1600" dirty="0">
+                <a:solidFill>
+                  <a:srgbClr val="13131A"/>
+                </a:solidFill>
+              </a:rPr>
+              <a:t>7.  Apply a threshold τ to turn probabilities into class decisions</a:t>
+            </a:r>
+            <a:endParaRPr lang="en-US" sz="1600" dirty="0"/>
+          </a:p>
+          <a:p>
+            <a:pPr>
+              <a:spcBef>
+                <a:spcPts val="500"/>
+              </a:spcBef>
+              <a:spcAft>
+                <a:spcPts val="500"/>
+              </a:spcAft>
+            </a:pPr>
+            <a:r>
+              <a:rPr lang="en-US" b="1" dirty="0">
+                <a:solidFill>
+                  <a:srgbClr val="13131A"/>
+                </a:solidFill>
+              </a:rPr>
+              <a:t>You should now be able to</a:t>
+            </a:r>
+            <a:endParaRPr lang="en-US" dirty="0"/>
           </a:p>
           <a:p>
             <a:pPr marL="285750" indent="-285750">
@@ -7966,33 +7857,14 @@
               <a:buChar char="•"/>
             </a:pPr>
             <a:r>
-              <a:rPr lang="en-US" sz="1500">
-                <a:solidFill>
-                  <a:srgbClr val="13131A"/>
-                </a:solidFill>
-              </a:rPr>
-              <a:t>Multinomial (softmax) regression extends the same log-odds idea to K classes</a:t>
-            </a:r>
-            <a:endParaRPr lang="en-US" sz="1500"/>
-          </a:p>
-          <a:p>
-            <a:pPr>
-              <a:spcBef>
-                <a:spcPts val="500"/>
-              </a:spcBef>
-              <a:spcAft>
-                <a:spcPts val="500"/>
-              </a:spcAft>
-            </a:pPr>
-            <a:r>
-              <a:rPr lang="en-US" sz="1600" b="1">
-                <a:solidFill>
-                  <a:srgbClr val="13131A"/>
-                </a:solidFill>
-              </a:rPr>
-              <a:t>Controlling overfitting</a:t>
-            </a:r>
-            <a:endParaRPr lang="en-US" sz="1600"/>
+              <a:rPr lang="en-US" sz="1600" dirty="0">
+                <a:solidFill>
+                  <a:srgbClr val="13131A"/>
+                </a:solidFill>
+              </a:rPr>
+              <a:t>Compute a predicted probability from w, b, and x by hand</a:t>
+            </a:r>
+            <a:endParaRPr lang="en-US" sz="1600" dirty="0"/>
           </a:p>
           <a:p>
             <a:pPr marL="285750" indent="-285750">
@@ -8006,14 +7878,14 @@
               <a:buChar char="•"/>
             </a:pPr>
             <a:r>
-              <a:rPr lang="en-US" sz="1500">
-                <a:solidFill>
-                  <a:srgbClr val="13131A"/>
-                </a:solidFill>
-              </a:rPr>
-              <a:t>L2 (ridge) and L1 (lasso) penalties shrink w; L1 also performs feature selection</a:t>
-            </a:r>
-            <a:endParaRPr lang="en-US" sz="1500"/>
+              <a:rPr lang="en-US" sz="1600" dirty="0">
+                <a:solidFill>
+                  <a:srgbClr val="13131A"/>
+                </a:solidFill>
+              </a:rPr>
+              <a:t>Interpret any coefficient as an odds ratio, and say why it is not a probability change</a:t>
+            </a:r>
+            <a:endParaRPr lang="en-US" sz="1600" dirty="0"/>
           </a:p>
           <a:p>
             <a:pPr marL="285750" indent="-285750">
@@ -8027,94 +7899,14 @@
               <a:buChar char="•"/>
             </a:pPr>
             <a:r>
-              <a:rPr lang="en-US" sz="1500">
-                <a:solidFill>
-                  <a:srgbClr val="13131A"/>
-                </a:solidFill>
-              </a:rPr>
-              <a:t>Regularization keeps the fit stable when features are many or correlated</a:t>
-            </a:r>
-            <a:endParaRPr lang="en-US" sz="1500"/>
-          </a:p>
-          <a:p>
-            <a:pPr>
-              <a:spcBef>
-                <a:spcPts val="500"/>
-              </a:spcBef>
-              <a:spcAft>
-                <a:spcPts val="500"/>
-              </a:spcAft>
-            </a:pPr>
-            <a:r>
-              <a:rPr lang="en-US" sz="1600" b="1">
-                <a:solidFill>
-                  <a:srgbClr val="13131A"/>
-                </a:solidFill>
-              </a:rPr>
-              <a:t>When fitting breaks down</a:t>
-            </a:r>
-            <a:endParaRPr lang="en-US" sz="1600"/>
-          </a:p>
-          <a:p>
-            <a:pPr marL="285750" indent="-285750">
-              <a:spcBef>
-                <a:spcPts val="500"/>
-              </a:spcBef>
-              <a:spcAft>
-                <a:spcPts val="500"/>
-              </a:spcAft>
-              <a:buFont typeface="Arial" panose="020B0604020202020204" pitchFamily="34" charset="0"/>
-              <a:buChar char="•"/>
-            </a:pPr>
-            <a:r>
-              <a:rPr lang="en-US" sz="1500">
-                <a:solidFill>
-                  <a:srgbClr val="13131A"/>
-                </a:solidFill>
-              </a:rPr>
-              <a:t>Perfect separation: if a feature splits the classes cleanly, the weights diverge to infinity — regularization is the standard fix</a:t>
-            </a:r>
-            <a:endParaRPr lang="en-US" sz="1500"/>
-          </a:p>
-          <a:p>
-            <a:pPr>
-              <a:spcBef>
-                <a:spcPts val="500"/>
-              </a:spcBef>
-              <a:spcAft>
-                <a:spcPts val="500"/>
-              </a:spcAft>
-            </a:pPr>
-            <a:r>
-              <a:rPr lang="en-US" sz="1600" b="1">
-                <a:solidFill>
-                  <a:srgbClr val="13131A"/>
-                </a:solidFill>
-              </a:rPr>
-              <a:t>Evaluating the classifier</a:t>
-            </a:r>
-            <a:endParaRPr lang="en-US" sz="1600"/>
-          </a:p>
-          <a:p>
-            <a:pPr marL="285750" indent="-285750">
-              <a:spcBef>
-                <a:spcPts val="500"/>
-              </a:spcBef>
-              <a:spcAft>
-                <a:spcPts val="500"/>
-              </a:spcAft>
-              <a:buFont typeface="Arial" panose="020B0604020202020204" pitchFamily="34" charset="0"/>
-              <a:buChar char="•"/>
-            </a:pPr>
-            <a:r>
-              <a:rPr lang="en-US" sz="1500">
-                <a:solidFill>
-                  <a:srgbClr val="13131A"/>
-                </a:solidFill>
-              </a:rPr>
-              <a:t>Confusion matrix, precision, recall, ROC/AUC — how we judge a threshold choice</a:t>
-            </a:r>
-            <a:endParaRPr lang="en-US" sz="1500"/>
+              <a:rPr lang="en-US" sz="1600" dirty="0">
+                <a:solidFill>
+                  <a:srgbClr val="13131A"/>
+                </a:solidFill>
+              </a:rPr>
+              <a:t>Justify a threshold from the relative cost of the two error types</a:t>
+            </a:r>
+            <a:endParaRPr lang="en-US" sz="1600" dirty="0"/>
           </a:p>
         </p:txBody>
       </p:sp>
@@ -10614,7 +10406,7 @@
                   <a:srgbClr val="13131A"/>
                 </a:solidFill>
               </a:rPr>
-              <a:t>A common trap</a:t>
+              <a:t>Note</a:t>
             </a:r>
             <a:endParaRPr lang="en-US" sz="1500" dirty="0"/>
           </a:p>

</xml_diff>